<commit_message>
Deck and walkthrough read the same numbers, each with its set and instrument
</commit_message>
<xml_diff>
--- a/deliverables/checkbox-approach.pptx
+++ b/deliverables/checkbox-approach.pptx
@@ -727,7 +727,7 @@
           <a:lstStyle/>
           <a:p>
             <a:r>
-              <a:t>A green test that would pass anyway is worse than no test, so two of the gates were verified by deliberately breaking the fix and watching them fail. The rejected-candidates field is the one I would check first, because rejection is the only place the system removes something instead of flagging it.</a:t>
+              <a:t>The rejected-candidates field is the one I would check first, because rejection is the only place the system removes something instead of flagging it.</a:t>
             </a:r>
           </a:p>
         </p:txBody>
@@ -867,7 +867,7 @@
           <a:lstStyle/>
           <a:p>
             <a:r>
-              <a:t>The LLM that built the product wrote both contestants, the rules and this 29KB model, and judged them against one referee: 52 damaged pages plus the hand-ruled answer keys. When the CNN is confident it is right 229 of 230 times, so training worked; its problem is confidence in the right places, 56 unsure boxes where the rules are sure and correct. make compare reprints this table from the repo.</a:t>
+              <a:t>The LLM that built the product wrote both contestants, the rules and this 23,381-weight model, and judged them against one referee: 52 damaged pages plus the hand-ruled answer keys. When the CNN is confident it is right 229 of 230 times, so training worked. Its problem is confidence in the right places, 56 unsure boxes where the rules are sure and correct. The 286 graded boxes are the 287 detections on the brief pages minus the one on the tick the labeler ruled unsure. Scoring a 118-box page takes it 4 ms on CPU (make bench-cnn). make compare reprints this table from the repo.</a:t>
             </a:r>
           </a:p>
         </p:txBody>
@@ -6074,7 +6074,7 @@
               </a:defRPr>
             </a:pPr>
             <a:r>
-              <a:t>Across 61 pages and 5,872 boxes, including 52 damaged on purpose, it never drops below 96.5% correct under any kind of damage.</a:t>
+              <a:t>On the 52 pages damaged on purpose, the box-finding score, F1, never drops below 0.965 under any kind of damage, and shading is the floor.</a:t>
             </a:r>
           </a:p>
         </p:txBody>
@@ -7253,7 +7253,7 @@
               </a:defRPr>
             </a:pPr>
             <a:r>
-              <a:t>Reprints the results table from scratch and runs 26 gates. Two of those gates I checked by reverting the fix and confirming they fail.</a:t>
+              <a:t>Reprints the results table from scratch and runs 26 gates.</a:t>
             </a:r>
           </a:p>
         </p:txBody>
@@ -8624,7 +8624,7 @@
               </a:defRPr>
             </a:pPr>
             <a:r>
-              <a:t>284 ms</a:t>
+              <a:t>273 ms</a:t>
             </a:r>
           </a:p>
         </p:txBody>
@@ -8833,7 +8833,7 @@
               </a:defRPr>
             </a:pPr>
             <a:r>
-              <a:t>0.92</a:t>
+              <a:t>0.95</a:t>
             </a:r>
           </a:p>
         </p:txBody>
@@ -8872,7 +8872,7 @@
               </a:defRPr>
             </a:pPr>
             <a:r>
-              <a:t>36 of 39 rulings</a:t>
+              <a:t>36 of 38 rulings</a:t>
             </a:r>
           </a:p>
         </p:txBody>
@@ -11304,7 +11304,7 @@
               </a:defRPr>
             </a:pPr>
             <a:r>
-              <a:t>All three are nearly errorless; they differ in how much they hand to people, 2 against 19 against 56. Most automation at the same accuracy wins.</a:t>
+              <a:t>All three are nearly errorless on the 286 graded boxes, the 287 detections on the brief pages minus the tick ruled unsure. They differ in how much they hand to people, 2 against 19 against 56. Most automation at the same accuracy wins.</a:t>
             </a:r>
           </a:p>
         </p:txBody>
@@ -11359,7 +11359,7 @@
               </a:defRPr>
             </a:pPr>
             <a:r>
-              <a:t>It caught nothing the rules missed, and misread both real never-seen test boxes.</a:t>
+              <a:t>It caught nothing the rules missed. On the two hard boxes on the photographed page it settled neither, queuing the empty pen loop at p(filled) 0.845 and reading the filled faded X as empty at 0.082.</a:t>
             </a:r>
           </a:p>
           <a:p>
@@ -13792,7 +13792,7 @@
               </a:defRPr>
             </a:pPr>
             <a:r>
-              <a:t>97.6% of boxes never leave the top row. 2.4% carry a reason code into the queue. Nothing in the top row is a model.</a:t>
+              <a:t>97.6% of boxes never leave the top row. 2.4% carry a reason code into the queue, measured over 61 pages. Nothing in the top row is a model.</a:t>
             </a:r>
           </a:p>
         </p:txBody>
@@ -14808,9 +14808,9 @@
                 <a:tableStyleId>{5C22544A-7EE6-4342-B048-85BDC9FD1C3A}</a:tableStyleId>
               </a:tblPr>
               <a:tblGrid>
-                <a:gridCol w="4878458"/>
-                <a:gridCol w="1951383"/>
-                <a:gridCol w="4227997"/>
+                <a:gridCol w="4253015"/>
+                <a:gridCol w="3118877"/>
+                <a:gridCol w="3685946"/>
               </a:tblGrid>
               <a:tr h="310896">
                 <a:tc>
@@ -14819,7 +14819,7 @@
                     <a:lstStyle/>
                     <a:p>
                       <a:pPr>
-                        <a:defRPr sz="1500" b="1">
+                        <a:defRPr sz="1400" b="1">
                           <a:solidFill>
                             <a:srgbClr val="FFFFFF"/>
                           </a:solidFill>
@@ -14843,7 +14843,7 @@
                     <a:lstStyle/>
                     <a:p>
                       <a:pPr>
-                        <a:defRPr sz="1500" b="1">
+                        <a:defRPr sz="1400" b="1">
                           <a:solidFill>
                             <a:srgbClr val="FFFFFF"/>
                           </a:solidFill>
@@ -14851,7 +14851,7 @@
                         </a:defRPr>
                       </a:pPr>
                       <a:r>
-                        <a:t>cost per page</a:t>
+                        <a:t>what a page costs</a:t>
                       </a:r>
                     </a:p>
                   </a:txBody>
@@ -14867,7 +14867,7 @@
                     <a:lstStyle/>
                     <a:p>
                       <a:pPr>
-                        <a:defRPr sz="1500" b="1">
+                        <a:defRPr sz="1400" b="1">
                           <a:solidFill>
                             <a:srgbClr val="FFFFFF"/>
                           </a:solidFill>
@@ -14875,7 +14875,7 @@
                         </a:defRPr>
                       </a:pPr>
                       <a:r>
-                        <a:t>note</a:t>
+                        <a:t>measured where</a:t>
                       </a:r>
                     </a:p>
                   </a:txBody>
@@ -14893,7 +14893,7 @@
                     <a:lstStyle/>
                     <a:p>
                       <a:pPr>
-                        <a:defRPr sz="1500" b="0">
+                        <a:defRPr sz="1400" b="0">
                           <a:solidFill>
                             <a:srgbClr val="18181B"/>
                           </a:solidFill>
@@ -14917,7 +14917,7 @@
                     <a:lstStyle/>
                     <a:p>
                       <a:pPr>
-                        <a:defRPr sz="1500" b="0">
+                        <a:defRPr sz="1400" b="0">
                           <a:solidFill>
                             <a:srgbClr val="18181B"/>
                           </a:solidFill>
@@ -14925,7 +14925,7 @@
                         </a:defRPr>
                       </a:pPr>
                       <a:r>
-                        <a:t>$0.000004</a:t>
+                        <a:t>273 ms of one CPU core, no model</a:t>
                       </a:r>
                     </a:p>
                   </a:txBody>
@@ -14941,7 +14941,7 @@
                     <a:lstStyle/>
                     <a:p>
                       <a:pPr>
-                        <a:defRPr sz="1500" b="0">
+                        <a:defRPr sz="1400" b="0">
                           <a:solidFill>
                             <a:srgbClr val="18181B"/>
                           </a:solidFill>
@@ -14949,7 +14949,7 @@
                         </a:defRPr>
                       </a:pPr>
                       <a:r>
-                        <a:t>0.30 s of one CPU core, no model</a:t>
+                        <a:t>make telemetry, median over 61 pages</a:t>
                       </a:r>
                     </a:p>
                   </a:txBody>
@@ -14967,7 +14967,7 @@
                     <a:lstStyle/>
                     <a:p>
                       <a:pPr>
-                        <a:defRPr sz="1500" b="0">
+                        <a:defRPr sz="1400" b="0">
                           <a:solidFill>
                             <a:srgbClr val="18181B"/>
                           </a:solidFill>
@@ -14991,7 +14991,7 @@
                     <a:lstStyle/>
                     <a:p>
                       <a:pPr>
-                        <a:defRPr sz="1500" b="0">
+                        <a:defRPr sz="1400" b="0">
                           <a:solidFill>
                             <a:srgbClr val="18181B"/>
                           </a:solidFill>
@@ -14999,7 +14999,7 @@
                         </a:defRPr>
                       </a:pPr>
                       <a:r>
-                        <a:t>$0.001</a:t>
+                        <a:t>one 107-token crop for 2 of 287 detections</a:t>
                       </a:r>
                     </a:p>
                   </a:txBody>
@@ -15015,7 +15015,7 @@
                     <a:lstStyle/>
                     <a:p>
                       <a:pPr>
-                        <a:defRPr sz="1500" b="0">
+                        <a:defRPr sz="1400" b="0">
                           <a:solidFill>
                             <a:srgbClr val="18181B"/>
                           </a:solidFill>
@@ -15023,7 +15023,7 @@
                         </a:defRPr>
                       </a:pPr>
                       <a:r>
-                        <a:t>at the measured 0.7% flag rate</a:t>
+                        <a:t>make telemetry and make crop-tokens, the 4 brief pages</a:t>
                       </a:r>
                     </a:p>
                   </a:txBody>
@@ -15041,7 +15041,7 @@
                     <a:lstStyle/>
                     <a:p>
                       <a:pPr>
-                        <a:defRPr sz="1500" b="0">
+                        <a:defRPr sz="1400" b="0">
                           <a:solidFill>
                             <a:srgbClr val="18181B"/>
                           </a:solidFill>
@@ -15065,7 +15065,7 @@
                     <a:lstStyle/>
                     <a:p>
                       <a:pPr>
-                        <a:defRPr sz="1500" b="0">
+                        <a:defRPr sz="1400" b="0">
                           <a:solidFill>
                             <a:srgbClr val="18181B"/>
                           </a:solidFill>
@@ -15073,7 +15073,7 @@
                         </a:defRPr>
                       </a:pPr>
                       <a:r>
-                        <a:t>$0.009</a:t>
+                        <a:t>56 of 847 boxes on the real pages</a:t>
                       </a:r>
                     </a:p>
                   </a:txBody>
@@ -15089,7 +15089,7 @@
                     <a:lstStyle/>
                     <a:p>
                       <a:pPr>
-                        <a:defRPr sz="1500" b="0">
+                        <a:defRPr sz="1400" b="0">
                           <a:solidFill>
                             <a:srgbClr val="18181B"/>
                           </a:solidFill>
@@ -15097,7 +15097,7 @@
                         </a:defRPr>
                       </a:pPr>
                       <a:r>
-                        <a:t>at the measured 6.6% flag rate</a:t>
+                        <a:t>make telemetry with the model on, brief plus held-out</a:t>
                       </a:r>
                     </a:p>
                   </a:txBody>
@@ -15115,7 +15115,7 @@
                     <a:lstStyle/>
                     <a:p>
                       <a:pPr>
-                        <a:defRPr sz="1500" b="0">
+                        <a:defRPr sz="1400" b="0">
                           <a:solidFill>
                             <a:srgbClr val="18181B"/>
                           </a:solidFill>
@@ -15139,7 +15139,7 @@
                     <a:lstStyle/>
                     <a:p>
                       <a:pPr>
-                        <a:defRPr sz="1500" b="0">
+                        <a:defRPr sz="1400" b="0">
                           <a:solidFill>
                             <a:srgbClr val="18181B"/>
                           </a:solidFill>
@@ -15147,7 +15147,7 @@
                         </a:defRPr>
                       </a:pPr>
                       <a:r>
-                        <a:t>$0.085</a:t>
+                        <a:t>the whole page, every page, priced per token</a:t>
                       </a:r>
                     </a:p>
                   </a:txBody>
@@ -15163,7 +15163,7 @@
                     <a:lstStyle/>
                     <a:p>
                       <a:pPr>
-                        <a:defRPr sz="1500" b="0">
+                        <a:defRPr sz="1400" b="0">
                           <a:solidFill>
                             <a:srgbClr val="18181B"/>
                           </a:solidFill>
@@ -15171,7 +15171,7 @@
                         </a:defRPr>
                       </a:pPr>
                       <a:r>
-                        <a:t>about 40x more, and weaker on checkboxes</a:t>
+                        <a:t>published work, docs/EVALS.md</a:t>
                       </a:r>
                     </a:p>
                   </a:txBody>
@@ -15236,7 +15236,7 @@
               </a:defRPr>
             </a:pPr>
             <a:r>
-              <a:t>A cropped checkbox is about 106 tokens of image. A whole page is about 1,990, and the answer runs to thousands more because it has to list every box and its coordinates.</a:t>
+              <a:t>A flagged box, zoomed in the way the escalation lane sends it, is about 107 tokens of image, the median over the 287 boxes on the brief pages. A whole page is the entire image, and the answer has to list every box and its coordinates on top of that.</a:t>
             </a:r>
           </a:p>
           <a:p>
@@ -15499,7 +15499,7 @@
               </a:defRPr>
             </a:pPr>
             <a:r>
-              <a:t>About a third of a second a page, and under half a second for 95 pages in every 100, measured over 61 pages. No network call in the path at all. Nothing waits on a vendor.</a:t>
+              <a:t>A median of 273 ms a page, and 301 ms for 95 pages in every 100, measured in-process over 61 pages. Through the HTTP service, 120 requests of the photographed page, the smallest of the four come back at a median of 50 ms. No network call in the path at all. Nothing waits on a vendor.</a:t>
             </a:r>
           </a:p>
           <a:p>
@@ -16579,7 +16579,7 @@
                         </a:defRPr>
                       </a:pPr>
                       <a:r>
-                        <a:t>cost per page</a:t>
+                        <a:t>what a page costs</a:t>
                       </a:r>
                     </a:p>
                   </a:txBody>
@@ -16603,7 +16603,7 @@
                         </a:defRPr>
                       </a:pPr>
                       <a:r>
-                        <a:t>$0.000004</a:t>
+                        <a:t>273 ms of one core, no model</a:t>
                       </a:r>
                     </a:p>
                   </a:txBody>
@@ -16627,7 +16627,7 @@
                         </a:defRPr>
                       </a:pPr>
                       <a:r>
-                        <a:t>about $0.010</a:t>
+                        <a:t>$10 per 1,000 pages, Azure list price</a:t>
                       </a:r>
                     </a:p>
                   </a:txBody>
@@ -16651,7 +16651,7 @@
                         </a:defRPr>
                       </a:pPr>
                       <a:r>
-                        <a:t>about $0.085</a:t>
+                        <a:t>the whole page, priced per token</a:t>
                       </a:r>
                     </a:p>
                   </a:txBody>
@@ -16701,7 +16701,7 @@
                         </a:defRPr>
                       </a:pPr>
                       <a:r>
-                        <a:t>0.30 s, local</a:t>
+                        <a:t>273 ms median, local</a:t>
                       </a:r>
                     </a:p>
                   </a:txBody>

</xml_diff>

<commit_message>
Count image tokens the way the vision doc bills them, name the bench machine, one decimal on the CNN time, and the cards at head
</commit_message>
<xml_diff>
--- a/deliverables/checkbox-approach.pptx
+++ b/deliverables/checkbox-approach.pptx
@@ -867,7 +867,7 @@
           <a:lstStyle/>
           <a:p>
             <a:r>
-              <a:t>The LLM that built the product wrote both contestants, the rules and this 23,381-weight model, and judged them against one referee: 52 damaged pages plus the hand-ruled answer keys. When the CNN is confident it is right 229 of 230 times, so training worked. Its problem is confidence in the right places, 56 unsure boxes where the rules are sure and correct. The 286 graded boxes are the 287 detections on the brief pages minus the one on the tick the labeler ruled unsure. Scoring a 118-box page takes it 4 ms on CPU (make bench-cnn). make compare reprints this table from the repo.</a:t>
+              <a:t>The LLM that built the product wrote both contestants, the rules and this 23,381-weight model, and judged them against one referee: 52 damaged pages plus the hand-ruled answer keys. When the CNN is confident it is right 229 of 230 times, so training worked. Its problem is confidence in the right places, 56 unsure boxes where the rules are sure and correct. The 286 graded boxes are the 287 detections on the brief pages minus the one on the tick the labeler ruled unsure. Scoring a 118-box page takes it 3.9 ms on CPU (make bench-cnn). make compare reprints this table from the repo.</a:t>
             </a:r>
           </a:p>
         </p:txBody>
@@ -14999,7 +14999,7 @@
                         </a:defRPr>
                       </a:pPr>
                       <a:r>
-                        <a:t>one 107-token crop for 2 of 287 detections</a:t>
+                        <a:t>one 110-token crop for 2 of 287 detections</a:t>
                       </a:r>
                     </a:p>
                   </a:txBody>
@@ -15236,7 +15236,7 @@
               </a:defRPr>
             </a:pPr>
             <a:r>
-              <a:t>A flagged box, zoomed in the way the escalation lane sends it, is about 107 tokens of image, the median over the 287 boxes on the brief pages. A whole page is the entire image, and the answer has to list every box and its coordinates on top of that.</a:t>
+              <a:t>A flagged box, zoomed in the way the escalation lane sends it, is about 110 tokens of image, the median over the 287 boxes on the brief pages. A whole page is the entire image, and the answer has to list every box and its coordinates on top of that.</a:t>
             </a:r>
           </a:p>
           <a:p>
@@ -16042,7 +16042,7 @@
               </a:defRPr>
             </a:pPr>
             <a:r>
-              <a:t>a number with an allowed range and a verdict; one sits outside its range today and says so</a:t>
+              <a:t>a number with an allowed range and a verdict; one sits outside its range and one is not yet measured against it, and both say so</a:t>
             </a:r>
           </a:p>
         </p:txBody>

</xml_diff>